<commit_message>
docs: rewrite intro and move tech concepts to methodology in ppt
</commit_message>
<xml_diff>
--- a/IntelliScreen_Presentation.pptx
+++ b/IntelliScreen_Presentation.pptx
@@ -18,6 +18,7 @@
     <p:sldId id="268" r:id="rId10"/>
     <p:sldId id="262" r:id="rId11"/>
     <p:sldId id="263" r:id="rId13"/>
+    <p:sldId id="273" r:id="rId23"/>
     <p:sldId id="264" r:id="rId14"/>
     <p:sldId id="271" r:id="rId15"/>
     <p:sldId id="272" r:id="rId16"/>
@@ -3939,6 +3940,103 @@
 </p:sld>
 </file>
 
+<file path=ppt/slides/slide17.xml><?xml version="1.0" encoding="utf-8"?>
+<p:sld xmlns:a="http://schemas.openxmlformats.org/drawingml/2006/main" xmlns:p="http://schemas.openxmlformats.org/presentationml/2006/main" xmlns:r="http://schemas.openxmlformats.org/officeDocument/2006/relationships">
+  <p:cSld>
+    <p:spTree>
+      <p:nvGrpSpPr>
+        <p:cNvPr id="1" name=""/>
+        <p:cNvGrpSpPr/>
+        <p:nvPr/>
+      </p:nvGrpSpPr>
+      <p:grpSpPr/>
+      <p:sp>
+        <p:nvSpPr>
+          <p:cNvPr id="2" name="Title 1"/>
+          <p:cNvSpPr>
+            <a:spLocks noGrp="1"/>
+          </p:cNvSpPr>
+          <p:nvPr>
+            <p:ph type="title"/>
+          </p:nvPr>
+        </p:nvSpPr>
+        <p:spPr/>
+        <p:txBody>
+          <a:bodyPr/>
+          <a:lstStyle/>
+          <a:p>
+            <a:r>
+              <a:t>Methodology: Core Technical Concepts</a:t>
+            </a:r>
+          </a:p>
+        </p:txBody>
+      </p:sp>
+      <p:sp>
+        <p:nvSpPr>
+          <p:cNvPr id="3" name="Text Placeholder 2"/>
+          <p:cNvSpPr>
+            <a:spLocks noGrp="1"/>
+          </p:cNvSpPr>
+          <p:nvPr>
+            <p:ph type="body" idx="1"/>
+          </p:nvPr>
+        </p:nvSpPr>
+        <p:spPr/>
+        <p:txBody>
+          <a:bodyPr/>
+          <a:lstStyle/>
+          <a:p>
+            <a:r>
+              <a:t>Technical Concepts:</a:t>
+            </a:r>
+          </a:p>
+          <a:p/>
+          <a:p>
+            <a:r>
+              <a:t>Multi-Metric Identity Verification: Live landmark-based geometric matching (inter-eye distance, face area, aspect ratio) against a baseline check-in photo.</a:t>
+            </a:r>
+          </a:p>
+          <a:p>
+            <a:r>
+              <a:t>Face Localization: OpenCV YuNet (convolutional face detector via ONNX).</a:t>
+            </a:r>
+          </a:p>
+          <a:p>
+            <a:r>
+              <a:t>Dense Mesh &amp; Iris Landmarks: MediaPipe FaceLandmarker with 478 3D vertices and Eye Aspect Ratio (EAR).</a:t>
+            </a:r>
+          </a:p>
+          <a:p>
+            <a:r>
+              <a:t>Head Pose Estimation: Perspective-n-Point (PnP) algorithm with Levenberg-Marquardt optimization matching 2D facial anchors to a 3D anthropometric face model.</a:t>
+            </a:r>
+          </a:p>
+          <a:p>
+            <a:r>
+              <a:t>Gaze Tracking: Dampened iris horizontal/vertical displacement ratios fused with 3D pose vectors.</a:t>
+            </a:r>
+          </a:p>
+          <a:p>
+            <a:r>
+              <a:t>Unauthorized Object Detection: Ultralytics YOLOv8n (COCO object classification for phones, books, laptops, secondary persons).</a:t>
+            </a:r>
+          </a:p>
+          <a:p>
+            <a:r>
+              <a:t>Temporal Event Tracking: Debounced condition state machine with a 30-second rolling sliding window.</a:t>
+            </a:r>
+          </a:p>
+          <a:p/>
+        </p:txBody>
+      </p:sp>
+    </p:spTree>
+  </p:cSld>
+  <p:clrMapOvr>
+    <a:masterClrMapping/>
+  </p:clrMapOvr>
+</p:sld>
+</file>
+
 <file path=ppt/slides/slide2.xml><?xml version="1.0" encoding="utf-8"?>
 <p:sld xmlns:a="http://schemas.openxmlformats.org/drawingml/2006/main" xmlns:r="http://schemas.openxmlformats.org/officeDocument/2006/relationships" xmlns:p="http://schemas.openxmlformats.org/presentationml/2006/main">
   <p:cSld>
@@ -4299,143 +4397,25 @@
           </a:bodyPr>
           <a:lstStyle/>
           <a:p>
-            <a:pPr>
-              <a:lnSpc>
-                <a:spcPct val="150000"/>
-              </a:lnSpc>
-            </a:pPr>
-            <a:r>
-              <a:rPr lang="en-IN" sz="2400" b="1" dirty="0">
-                <a:latin typeface="Arial MT"/>
-              </a:rPr>
-              <a:t>Technical Concepts:</a:t>
-            </a:r>
-            <a:endParaRPr lang="en-IN" sz="2400" b="1" dirty="0">
-              <a:latin typeface="Arial MT"/>
-            </a:endParaRPr>
-          </a:p>
-          <a:p>
-            <a:pPr marL="342900" lvl="0" indent="-342900">
-              <a:lnSpc>
-                <a:spcPct val="150000"/>
-              </a:lnSpc>
-              <a:buFont typeface="Arial" panose="020B0604020202020204" pitchFamily="34" charset="0"/>
-              <a:buChar char="•"/>
-            </a:pPr>
-            <a:endParaRPr lang="en-US" altLang="en-US" sz="1800" b="1" dirty="0"/>
-          </a:p>
-          <a:p>
-            <a:pPr marL="342900" lvl="0" indent="-342900">
-              <a:lnSpc>
-                <a:spcPct val="150000"/>
-              </a:lnSpc>
-              <a:buFont typeface="Arial" panose="020B0604020202020204" pitchFamily="34" charset="0"/>
-              <a:buChar char="•"/>
-            </a:pPr>
-            <a:r>
-              <a:t>Multi-Metric Identity Verification: Live landmark-based geometric matching (inter-eye distance, face area, aspect ratio) against a baseline check-in photo.
-Face Localization: OpenCV YuNet (convolutional face detector via ONNX).</a:t>
-            </a:r>
-            <a:endParaRPr lang="en-US" altLang="en-US" sz="1800" b="0" dirty="0"/>
-          </a:p>
-          <a:p>
-            <a:pPr marL="342900" lvl="0" indent="-342900">
-              <a:lnSpc>
-                <a:spcPct val="150000"/>
-              </a:lnSpc>
-              <a:buFont typeface="Arial" panose="020B0604020202020204" pitchFamily="34" charset="0"/>
-              <a:buChar char="•"/>
-            </a:pPr>
-            <a:r>
-              <a:rPr lang="en-US" altLang="en-US" sz="1800" b="1" dirty="0"/>
-              <a:t>Dense Mesh &amp; Iris Landmarks: </a:t>
-            </a:r>
-            <a:r>
-              <a:rPr lang="en-US" altLang="en-US" sz="1800" b="0" dirty="0"/>
-              <a:t>MediaPipe FaceLandmarker with 478 3D vertices and Eye Aspect Ratio (EAR).</a:t>
-            </a:r>
-            <a:endParaRPr lang="en-US" altLang="en-US" sz="1800" b="0" dirty="0"/>
-          </a:p>
-          <a:p>
-            <a:pPr marL="342900" lvl="0" indent="-342900">
-              <a:lnSpc>
-                <a:spcPct val="150000"/>
-              </a:lnSpc>
-              <a:buFont typeface="Arial" panose="020B0604020202020204" pitchFamily="34" charset="0"/>
-              <a:buChar char="•"/>
-            </a:pPr>
-            <a:r>
-              <a:rPr lang="en-US" altLang="en-US" sz="1800" b="1" dirty="0"/>
-              <a:t>Head Pose Estimation: </a:t>
-            </a:r>
-            <a:r>
-              <a:rPr lang="en-US" altLang="en-US" sz="1800" b="0" dirty="0"/>
-              <a:t>Perspective-n-Point (PnP) algorithm with Levenberg-Marquardt optimization matching 2D facial anchors to a 3D anthropometric face model.</a:t>
-            </a:r>
-            <a:endParaRPr lang="en-US" altLang="en-US" sz="1800" b="0" dirty="0"/>
-          </a:p>
-          <a:p>
-            <a:pPr marL="342900" lvl="0" indent="-342900">
-              <a:lnSpc>
-                <a:spcPct val="150000"/>
-              </a:lnSpc>
-              <a:buFont typeface="Arial" panose="020B0604020202020204" pitchFamily="34" charset="0"/>
-              <a:buChar char="•"/>
-            </a:pPr>
-            <a:r>
-              <a:t>Gaze Tracking: Dampened iris horizontal/vertical displacement ratios fused with 3D pose vectors.</a:t>
-            </a:r>
-            <a:endParaRPr lang="en-US" altLang="en-US" sz="1800" b="1" dirty="0"/>
-          </a:p>
-          <a:p>
-            <a:pPr marL="342900" lvl="0" indent="-342900">
-              <a:lnSpc>
-                <a:spcPct val="150000"/>
-              </a:lnSpc>
-              <a:buFont typeface="Arial" panose="020B0604020202020204" pitchFamily="34" charset="0"/>
-              <a:buChar char="•"/>
-            </a:pPr>
-            <a:r>
-              <a:rPr lang="en-US" altLang="en-US" sz="1800" b="1" dirty="0"/>
-              <a:t>Unauthorized Object Detection: </a:t>
-            </a:r>
-            <a:r>
-              <a:rPr lang="en-US" altLang="en-US" sz="1800" b="0" dirty="0"/>
-              <a:t>Ultralytics YOLOv8n (COCO object classification for phones, books, laptops, secondary persons).</a:t>
-            </a:r>
-            <a:endParaRPr lang="en-US" altLang="en-US" sz="1800" b="1" dirty="0"/>
-          </a:p>
-          <a:p>
-            <a:pPr marL="342900" lvl="0" indent="-342900">
-              <a:lnSpc>
-                <a:spcPct val="150000"/>
-              </a:lnSpc>
-              <a:buFont typeface="Arial" panose="020B0604020202020204" pitchFamily="34" charset="0"/>
-              <a:buChar char="•"/>
-            </a:pPr>
-            <a:r>
-              <a:rPr lang="en-US" altLang="en-US" sz="1800" b="1" dirty="0"/>
-              <a:t>Temporal Event Tracking: </a:t>
-            </a:r>
-            <a:r>
-              <a:rPr lang="en-US" altLang="en-US" sz="1800" b="0" dirty="0"/>
-              <a:t>Debounced condition state machine with a 30-second rolling sliding window.</a:t>
-            </a:r>
-            <a:endParaRPr lang="en-US" altLang="en-US" sz="1800" b="0" dirty="0"/>
-          </a:p>
-          <a:p>
-            <a:pPr marL="12700">
-              <a:lnSpc>
-                <a:spcPct val="150000"/>
-              </a:lnSpc>
-              <a:spcBef>
-                <a:spcPts val="100"/>
-              </a:spcBef>
-            </a:pPr>
-            <a:endParaRPr lang="en-US" altLang="en-US" sz="1800" b="0" dirty="0">
-              <a:latin typeface="Arial MT"/>
-              <a:cs typeface="Arial MT"/>
-            </a:endParaRPr>
+            <a:r>
+              <a:t>Project Overview</a:t>
+            </a:r>
+          </a:p>
+          <a:p/>
+          <a:p>
+            <a:r>
+              <a:t>• IntelliScreen is a context-aware, AI-powered online examination and proctoring platform designed specifically for secure, large-scale remote assessments (such as MCQs and text-based exams).</a:t>
+            </a:r>
+          </a:p>
+          <a:p>
+            <a:r>
+              <a:t>• It operates using a scalable microservice architecture to ensure maximum privacy, high concurrency, and ultra-low latency.</a:t>
+            </a:r>
+          </a:p>
+          <a:p>
+            <a:r>
+              <a:t>• Unlike legacy systems, IntelliScreen evaluates candidate behavior using a unique temporal sliding window rather than strict, instantaneous rule-based bans, minimizing false alarms from natural cognitive behaviors.</a:t>
+            </a:r>
           </a:p>
         </p:txBody>
       </p:sp>

</xml_diff>